<commit_message>
chore: add size measures to the architecture diagram
</commit_message>
<xml_diff>
--- a/docs/assets/architecture.pptx
+++ b/docs/assets/architecture.pptx
@@ -243,7 +243,7 @@
           <a:p>
             <a:fld id="{B94E6B3F-463D-6F44-8A03-5425760B063A}" type="datetimeFigureOut">
               <a:rPr lang="en-US" smtClean="0"/>
-              <a:t>9/21/26</a:t>
+              <a:t>10/5/26</a:t>
             </a:fld>
             <a:endParaRPr lang="en-US"/>
           </a:p>
@@ -413,7 +413,7 @@
           <a:p>
             <a:fld id="{B94E6B3F-463D-6F44-8A03-5425760B063A}" type="datetimeFigureOut">
               <a:rPr lang="en-US" smtClean="0"/>
-              <a:t>9/21/26</a:t>
+              <a:t>10/5/26</a:t>
             </a:fld>
             <a:endParaRPr lang="en-US"/>
           </a:p>
@@ -593,7 +593,7 @@
           <a:p>
             <a:fld id="{B94E6B3F-463D-6F44-8A03-5425760B063A}" type="datetimeFigureOut">
               <a:rPr lang="en-US" smtClean="0"/>
-              <a:t>9/21/26</a:t>
+              <a:t>10/5/26</a:t>
             </a:fld>
             <a:endParaRPr lang="en-US"/>
           </a:p>
@@ -763,7 +763,7 @@
           <a:p>
             <a:fld id="{B94E6B3F-463D-6F44-8A03-5425760B063A}" type="datetimeFigureOut">
               <a:rPr lang="en-US" smtClean="0"/>
-              <a:t>9/21/26</a:t>
+              <a:t>10/5/26</a:t>
             </a:fld>
             <a:endParaRPr lang="en-US"/>
           </a:p>
@@ -1009,7 +1009,7 @@
           <a:p>
             <a:fld id="{B94E6B3F-463D-6F44-8A03-5425760B063A}" type="datetimeFigureOut">
               <a:rPr lang="en-US" smtClean="0"/>
-              <a:t>9/21/26</a:t>
+              <a:t>10/5/26</a:t>
             </a:fld>
             <a:endParaRPr lang="en-US"/>
           </a:p>
@@ -1241,7 +1241,7 @@
           <a:p>
             <a:fld id="{B94E6B3F-463D-6F44-8A03-5425760B063A}" type="datetimeFigureOut">
               <a:rPr lang="en-US" smtClean="0"/>
-              <a:t>9/21/26</a:t>
+              <a:t>10/5/26</a:t>
             </a:fld>
             <a:endParaRPr lang="en-US"/>
           </a:p>
@@ -1608,7 +1608,7 @@
           <a:p>
             <a:fld id="{B94E6B3F-463D-6F44-8A03-5425760B063A}" type="datetimeFigureOut">
               <a:rPr lang="en-US" smtClean="0"/>
-              <a:t>9/21/26</a:t>
+              <a:t>10/5/26</a:t>
             </a:fld>
             <a:endParaRPr lang="en-US"/>
           </a:p>
@@ -1726,7 +1726,7 @@
           <a:p>
             <a:fld id="{B94E6B3F-463D-6F44-8A03-5425760B063A}" type="datetimeFigureOut">
               <a:rPr lang="en-US" smtClean="0"/>
-              <a:t>9/21/26</a:t>
+              <a:t>10/5/26</a:t>
             </a:fld>
             <a:endParaRPr lang="en-US"/>
           </a:p>
@@ -1821,7 +1821,7 @@
           <a:p>
             <a:fld id="{B94E6B3F-463D-6F44-8A03-5425760B063A}" type="datetimeFigureOut">
               <a:rPr lang="en-US" smtClean="0"/>
-              <a:t>9/21/26</a:t>
+              <a:t>10/5/26</a:t>
             </a:fld>
             <a:endParaRPr lang="en-US"/>
           </a:p>
@@ -2098,7 +2098,7 @@
           <a:p>
             <a:fld id="{B94E6B3F-463D-6F44-8A03-5425760B063A}" type="datetimeFigureOut">
               <a:rPr lang="en-US" smtClean="0"/>
-              <a:t>9/21/26</a:t>
+              <a:t>10/5/26</a:t>
             </a:fld>
             <a:endParaRPr lang="en-US"/>
           </a:p>
@@ -2351,7 +2351,7 @@
           <a:p>
             <a:fld id="{B94E6B3F-463D-6F44-8A03-5425760B063A}" type="datetimeFigureOut">
               <a:rPr lang="en-US" smtClean="0"/>
-              <a:t>9/21/26</a:t>
+              <a:t>10/5/26</a:t>
             </a:fld>
             <a:endParaRPr lang="en-US"/>
           </a:p>
@@ -2564,7 +2564,7 @@
           <a:p>
             <a:fld id="{B94E6B3F-463D-6F44-8A03-5425760B063A}" type="datetimeFigureOut">
               <a:rPr lang="en-US" smtClean="0"/>
-              <a:t>9/21/26</a:t>
+              <a:t>10/5/26</a:t>
             </a:fld>
             <a:endParaRPr lang="en-US"/>
           </a:p>
@@ -3738,9 +3738,9 @@
         <p:grpSpPr>
           <a:xfrm>
             <a:off x="2893296" y="2984632"/>
-            <a:ext cx="2801534" cy="1141009"/>
+            <a:ext cx="2801534" cy="1244957"/>
             <a:chOff x="2957945" y="58882"/>
-            <a:chExt cx="2801534" cy="1141009"/>
+            <a:chExt cx="2801534" cy="1244957"/>
           </a:xfrm>
         </p:grpSpPr>
         <p:grpSp>
@@ -3758,9 +3758,9 @@
           <p:grpSpPr>
             <a:xfrm>
               <a:off x="2957945" y="58882"/>
-              <a:ext cx="2801534" cy="1141009"/>
+              <a:ext cx="2801534" cy="1244957"/>
               <a:chOff x="3380509" y="367146"/>
-              <a:chExt cx="2556164" cy="1336964"/>
+              <a:chExt cx="2556164" cy="1458764"/>
             </a:xfrm>
           </p:grpSpPr>
           <p:sp>
@@ -3777,8 +3777,8 @@
             </p:nvSpPr>
             <p:spPr>
               <a:xfrm>
-                <a:off x="3380509" y="568037"/>
-                <a:ext cx="2556164" cy="1136073"/>
+                <a:off x="3380509" y="568036"/>
+                <a:ext cx="2556164" cy="1257874"/>
               </a:xfrm>
               <a:prstGeom prst="rect">
                 <a:avLst/>
@@ -3898,7 +3898,7 @@
           <p:spPr>
             <a:xfrm>
               <a:off x="2996045" y="318655"/>
-              <a:ext cx="2722058" cy="819173"/>
+              <a:ext cx="2722058" cy="951893"/>
             </a:xfrm>
             <a:prstGeom prst="rect">
               <a:avLst/>
@@ -3960,7 +3960,7 @@
           <p:spPr>
             <a:xfrm>
               <a:off x="3046267" y="555622"/>
-              <a:ext cx="845127" cy="519546"/>
+              <a:ext cx="1261048" cy="288000"/>
             </a:xfrm>
             <a:prstGeom prst="rect">
               <a:avLst/>
@@ -3993,7 +3993,7 @@
             </a:fontRef>
           </p:style>
           <p:txBody>
-            <a:bodyPr lIns="216000" tIns="36000" rIns="0" bIns="36000" rtlCol="0" anchor="ctr"/>
+            <a:bodyPr lIns="288000" tIns="36000" rIns="0" bIns="36000" rtlCol="0" anchor="ctr"/>
             <a:lstStyle/>
             <a:p>
               <a:pPr algn="ctr"/>
@@ -4022,8 +4022,8 @@
           </p:nvSpPr>
           <p:spPr>
             <a:xfrm>
-              <a:off x="3941616" y="557645"/>
-              <a:ext cx="845127" cy="519546"/>
+              <a:off x="3049251" y="913897"/>
+              <a:ext cx="1260000" cy="288000"/>
             </a:xfrm>
             <a:prstGeom prst="rect">
               <a:avLst/>
@@ -4085,8 +4085,8 @@
           </p:nvSpPr>
           <p:spPr>
             <a:xfrm>
-              <a:off x="4830044" y="557645"/>
-              <a:ext cx="845127" cy="519546"/>
+              <a:off x="4383467" y="557152"/>
+              <a:ext cx="1260000" cy="288000"/>
             </a:xfrm>
             <a:prstGeom prst="rect">
               <a:avLst/>
@@ -4150,13 +4150,13 @@
           <p:nvPr>
             <p:extLst>
               <p:ext uri="{D42A27DB-BD31-4B8C-83A1-F6EECF244321}">
-                <p14:modId xmlns:p14="http://schemas.microsoft.com/office/powerpoint/2010/main" val="3331289793"/>
+                <p14:modId xmlns:p14="http://schemas.microsoft.com/office/powerpoint/2010/main" val="1030599026"/>
               </p:ext>
             </p:extLst>
           </p:nvPr>
         </p:nvGraphicFramePr>
         <p:xfrm>
-          <a:off x="3018856" y="3656989"/>
+          <a:off x="3018856" y="3535069"/>
           <a:ext cx="211628" cy="182880"/>
         </p:xfrm>
         <a:graphic>
@@ -4291,7 +4291,7 @@
         </p:blipFill>
         <p:spPr>
           <a:xfrm>
-            <a:off x="3883491" y="3587026"/>
+            <a:off x="2981618" y="3846455"/>
             <a:ext cx="288000" cy="288000"/>
           </a:xfrm>
           <a:prstGeom prst="rect">
@@ -4327,7 +4327,7 @@
         </p:blipFill>
         <p:spPr>
           <a:xfrm>
-            <a:off x="4742129" y="3587026"/>
+            <a:off x="4330649" y="3487966"/>
             <a:ext cx="288000" cy="288000"/>
           </a:xfrm>
           <a:prstGeom prst="rect">
@@ -5334,9 +5334,9 @@
         <p:grpSpPr>
           <a:xfrm>
             <a:off x="51154" y="1511818"/>
-            <a:ext cx="2860257" cy="2115903"/>
+            <a:ext cx="2861469" cy="2115903"/>
             <a:chOff x="140787" y="1233459"/>
-            <a:chExt cx="2860257" cy="2115903"/>
+            <a:chExt cx="2861469" cy="2115903"/>
           </a:xfrm>
         </p:grpSpPr>
         <p:cxnSp>
@@ -5355,8 +5355,8 @@
           </p:nvCxnSpPr>
           <p:spPr>
             <a:xfrm flipH="1">
-              <a:off x="2829089" y="3090917"/>
-              <a:ext cx="171955" cy="6044"/>
+              <a:off x="2829089" y="3096961"/>
+              <a:ext cx="173167" cy="0"/>
             </a:xfrm>
             <a:prstGeom prst="straightConnector1">
               <a:avLst/>
@@ -8187,6 +8187,105 @@
           </a:p>
         </p:txBody>
       </p:sp>
+      <p:sp>
+        <p:nvSpPr>
+          <p:cNvPr id="3" name="Prostokąt 2">
+            <a:extLst>
+              <a:ext uri="{FF2B5EF4-FFF2-40B4-BE49-F238E27FC236}">
+                <a16:creationId xmlns:a16="http://schemas.microsoft.com/office/drawing/2014/main" id="{8B1A9071-27BB-A631-D01A-0BBAE0761A43}"/>
+              </a:ext>
+            </a:extLst>
+          </p:cNvPr>
+          <p:cNvSpPr/>
+          <p:nvPr/>
+        </p:nvSpPr>
+        <p:spPr>
+          <a:xfrm>
+            <a:off x="4318818" y="3839600"/>
+            <a:ext cx="1260000" cy="288000"/>
+          </a:xfrm>
+          <a:prstGeom prst="rect">
+            <a:avLst/>
+          </a:prstGeom>
+          <a:solidFill>
+            <a:srgbClr val="FFC000"/>
+          </a:solidFill>
+          <a:ln>
+            <a:solidFill>
+              <a:schemeClr val="accent5">
+                <a:lumMod val="75000"/>
+              </a:schemeClr>
+            </a:solidFill>
+          </a:ln>
+        </p:spPr>
+        <p:style>
+          <a:lnRef idx="2">
+            <a:schemeClr val="accent1">
+              <a:shade val="15000"/>
+            </a:schemeClr>
+          </a:lnRef>
+          <a:fillRef idx="1">
+            <a:schemeClr val="accent1"/>
+          </a:fillRef>
+          <a:effectRef idx="0">
+            <a:schemeClr val="accent1"/>
+          </a:effectRef>
+          <a:fontRef idx="minor">
+            <a:schemeClr val="lt1"/>
+          </a:fontRef>
+        </p:style>
+        <p:txBody>
+          <a:bodyPr lIns="144000" tIns="36000" rIns="0" bIns="36000" rtlCol="0" anchor="ctr"/>
+          <a:lstStyle/>
+          <a:p>
+            <a:pPr algn="ctr"/>
+            <a:r>
+              <a:rPr lang="en-US" sz="1000" dirty="0">
+                <a:solidFill>
+                  <a:schemeClr val="tx1"/>
+                </a:solidFill>
+              </a:rPr>
+              <a:t>Size-based</a:t>
+            </a:r>
+          </a:p>
+        </p:txBody>
+      </p:sp>
+      <p:pic>
+        <p:nvPicPr>
+          <p:cNvPr id="12" name="Grafika 11" descr="Szala sprawiedliwości z wypełnieniem pełnym">
+            <a:extLst>
+              <a:ext uri="{FF2B5EF4-FFF2-40B4-BE49-F238E27FC236}">
+                <a16:creationId xmlns:a16="http://schemas.microsoft.com/office/drawing/2014/main" id="{7797CE0C-ECF2-5A99-8145-B49D2411821E}"/>
+              </a:ext>
+            </a:extLst>
+          </p:cNvPr>
+          <p:cNvPicPr>
+            <a:picLocks noChangeAspect="1"/>
+          </p:cNvPicPr>
+          <p:nvPr/>
+        </p:nvPicPr>
+        <p:blipFill>
+          <a:blip>
+            <a:extLst>
+              <a:ext uri="{96DAC541-7B7A-43D3-8B79-37D633B846F1}">
+                <asvg:svgBlip xmlns:asvg="http://schemas.microsoft.com/office/drawing/2016/SVG/main" r:embed="rId12"/>
+              </a:ext>
+            </a:extLst>
+          </a:blip>
+          <a:stretch>
+            <a:fillRect/>
+          </a:stretch>
+        </p:blipFill>
+        <p:spPr>
+          <a:xfrm>
+            <a:off x="4328193" y="3832997"/>
+            <a:ext cx="288000" cy="288000"/>
+          </a:xfrm>
+          <a:prstGeom prst="rect">
+            <a:avLst/>
+          </a:prstGeom>
+        </p:spPr>
+      </p:pic>
     </p:spTree>
     <p:extLst>
       <p:ext uri="{BB962C8B-B14F-4D97-AF65-F5344CB8AC3E}">

</xml_diff>